<commit_message>
docs(data): add verified Market file manifest
</commit_message>
<xml_diff>
--- a/docs/slides/capstone_review_2026-08-09.pptx
+++ b/docs/slides/capstone_review_2026-08-09.pptx
@@ -6365,7 +6365,7 @@
               </a:defRPr>
             </a:pPr>
             <a:r>
-              <a:t>• [x] Market dataset card with counts, dates, label distribution, and checksums.</a:t>
+              <a:t>• [x] Market dataset card plus 20-file byte/SHA-256 manifest.</a:t>
             </a:r>
             <a:br/>
             <a:r>
@@ -7102,7 +7102,7 @@
             </a:r>
             <a:br/>
             <a:r>
-              <a:t>  Dataset:    Market/cloudbed-1 &lt;checksum + manifest path&gt;</a:t>
+              <a:t>  Dataset:    docs/review/market_cloudbed1_file_manifest_2026-08-09.tsv</a:t>
             </a:r>
             <a:br/>
             <a:r>
@@ -8192,7 +8192,11 @@
             </a:r>
             <a:br/>
             <a:r>
-              <a:t>labels, and 15 failure reasons. The dataset card preserves query/record checksums</a:t>
+              <a:t>labels, and 15 failure reasons. The dataset card and 20-file manifest preserve</a:t>
+            </a:r>
+            <a:br/>
+            <a:r>
+              <a:t>query/record checksums</a:t>
             </a:r>
             <a:br/>
             <a:r>

</xml_diff>

<commit_message>
docs(capstone): finalize teaching deck
</commit_message>
<xml_diff>
--- a/docs/slides/capstone_review_2026-08-09.pptx
+++ b/docs/slides/capstone_review_2026-08-09.pptx
@@ -22,6 +22,7 @@
     <p:sldId id="270" r:id="rId21"/>
     <p:sldId id="271" r:id="rId22"/>
     <p:sldId id="272" r:id="rId23"/>
+    <p:sldId id="273" r:id="rId24"/>
   </p:sldIdLst>
   <p:sldSz cx="12191695" cy="6858000" type="screen4x3"/>
   <p:notesSz cx="6858000" cy="9144000"/>
@@ -6238,7 +6239,7 @@
               </a:defRPr>
             </a:pPr>
             <a:r>
-              <a:t>Completeness gate</a:t>
+              <a:t>Contribution ownership — complete before final</a:t>
             </a:r>
           </a:p>
         </p:txBody>
@@ -6288,59 +6289,14 @@
       </p:sp>
       <p:sp>
         <p:nvSpPr>
-          <p:cNvPr id="5" name="Rounded Rectangle 4"/>
-          <p:cNvSpPr/>
-          <p:nvPr/>
-        </p:nvSpPr>
-        <p:spPr>
-          <a:xfrm>
-            <a:off x="603504" y="1097280"/>
-            <a:ext cx="10991088" cy="5221223"/>
-          </a:xfrm>
-          <a:prstGeom prst="roundRect">
-            <a:avLst/>
-          </a:prstGeom>
-          <a:solidFill>
-            <a:srgbClr val="142234"/>
-          </a:solidFill>
-          <a:ln>
-            <a:solidFill>
-              <a:srgbClr val="22364C"/>
-            </a:solidFill>
-          </a:ln>
-        </p:spPr>
-        <p:style>
-          <a:lnRef idx="1">
-            <a:schemeClr val="accent1"/>
-          </a:lnRef>
-          <a:fillRef idx="3">
-            <a:schemeClr val="accent1"/>
-          </a:fillRef>
-          <a:effectRef idx="2">
-            <a:schemeClr val="accent1"/>
-          </a:effectRef>
-          <a:fontRef idx="minor">
-            <a:schemeClr val="lt1"/>
-          </a:fontRef>
-        </p:style>
-        <p:txBody>
-          <a:bodyPr rtlCol="0" anchor="ctr"/>
-          <a:lstStyle/>
-          <a:p>
-            <a:pPr algn="ctr"/>
-          </a:p>
-        </p:txBody>
-      </p:sp>
-      <p:sp>
-        <p:nvSpPr>
-          <p:cNvPr id="6" name="TextBox 5"/>
+          <p:cNvPr id="5" name="TextBox 4"/>
           <p:cNvSpPr txBox="1"/>
           <p:nvPr/>
         </p:nvSpPr>
         <p:spPr>
           <a:xfrm>
-            <a:off x="768096" y="1207008"/>
-            <a:ext cx="10625328" cy="5038344"/>
+            <a:off x="658368" y="1133856"/>
+            <a:ext cx="10835640" cy="548640"/>
           </a:xfrm>
           <a:prstGeom prst="rect">
             <a:avLst/>
@@ -6357,7 +6313,7 @@
               <a:spcAft>
                 <a:spcPts val="200"/>
               </a:spcAft>
-              <a:defRPr sz="1550" b="0">
+              <a:defRPr sz="1450" b="0">
                 <a:solidFill>
                   <a:srgbClr val="F4F8FC"/>
                 </a:solidFill>
@@ -6365,55 +6321,536 @@
               </a:defRPr>
             </a:pPr>
             <a:r>
-              <a:t>• [x] Market dataset card plus 20-file byte/SHA-256 manifest.</a:t>
-            </a:r>
-            <a:br/>
-            <a:r>
-              <a:t>• [ ] Real-data preparation report and executed EDA figures.</a:t>
-            </a:r>
-            <a:br/>
-            <a:r>
-              <a:t>• [ ] One chosen submitted method, baseline, split, and metric definition.</a:t>
-            </a:r>
-            <a:br/>
-            <a:r>
-              <a:t>• [x] Metric-only loader/time-window contract tested on one real case.</a:t>
-            </a:r>
-            <a:br/>
-            <a:r>
-              <a:t>• [x] Full method run once against a disposable/local DB with no live write.</a:t>
-            </a:r>
-            <a:br/>
-            <a:r>
-              <a:t>• [ ] Per-case result table, ablation, two failures, one success.</a:t>
-            </a:r>
-            <a:br/>
-            <a:r>
-              <a:t>• [ ] UI/demo displays a real saved RCA or is scoped honestly.</a:t>
-            </a:r>
-            <a:br/>
-            <a:r>
-              <a:t>• [ ] Fresh-clone setup/run log and dependency/config manifest.</a:t>
-            </a:r>
-            <a:br/>
-            <a:r>
-              <a:t>• [ ] Citations, contributions, security, and limitations reviewed.</a:t>
-            </a:r>
-            <a:br/>
-            <a:br/>
-            <a:r>
-              <a:t>Completeness means that a teacher can trace dataset → query → telemetry → method</a:t>
-            </a:r>
-            <a:br/>
-            <a:r>
-              <a:t>→ prediction → ground truth → score without receiving a secret.</a:t>
-            </a:r>
-          </a:p>
-        </p:txBody>
-      </p:sp>
+              <a:t>Do not infer ownership from the final branch. Each student must add evidence for</a:t>
+            </a:r>
+            <a:br/>
+            <a:r>
+              <a:t>their own work before 15 August:</a:t>
+            </a:r>
+          </a:p>
+        </p:txBody>
+      </p:sp>
+      <p:graphicFrame>
+        <p:nvGraphicFramePr>
+          <p:cNvPr id="6" name="Table 5"/>
+          <p:cNvGraphicFramePr>
+            <a:graphicFrameLocks noGrp="1"/>
+          </p:cNvGraphicFramePr>
+          <p:nvPr/>
+        </p:nvGraphicFramePr>
+        <p:xfrm>
+          <a:off x="658368" y="1755648"/>
+          <a:ext cx="10835637" cy="3785615"/>
+        </p:xfrm>
+        <a:graphic>
+          <a:graphicData uri="http://schemas.openxmlformats.org/drawingml/2006/table">
+            <a:tbl>
+              <a:tblPr firstRow="1" bandRow="1">
+                <a:tableStyleId>{5C22544A-7EE6-4342-B048-85BDC9FD1C3A}</a:tableStyleId>
+              </a:tblPr>
+              <a:tblGrid>
+                <a:gridCol w="3611879"/>
+                <a:gridCol w="3611879"/>
+                <a:gridCol w="3611879"/>
+              </a:tblGrid>
+              <a:tr h="630935">
+                <a:tc>
+                  <a:txBody>
+                    <a:bodyPr/>
+                    <a:lstStyle/>
+                    <a:p>
+                      <a:pPr algn="l">
+                        <a:defRPr sz="1300" b="1">
+                          <a:solidFill>
+                            <a:srgbClr val="0A1422"/>
+                          </a:solidFill>
+                          <a:latin typeface="Aptos"/>
+                        </a:defRPr>
+                      </a:pPr>
+                      <a:r>
+                        <a:t>Area</a:t>
+                      </a:r>
+                    </a:p>
+                  </a:txBody>
+                  <a:tcPr marL="64008" marR="64008" marT="36576" marB="36576" anchor="ctr">
+                    <a:solidFill>
+                      <a:srgbClr val="3A96FF"/>
+                    </a:solidFill>
+                  </a:tcPr>
+                </a:tc>
+                <a:tc>
+                  <a:txBody>
+                    <a:bodyPr/>
+                    <a:lstStyle/>
+                    <a:p>
+                      <a:pPr algn="l">
+                        <a:defRPr sz="1300" b="1">
+                          <a:solidFill>
+                            <a:srgbClr val="0A1422"/>
+                          </a:solidFill>
+                          <a:latin typeface="Aptos"/>
+                        </a:defRPr>
+                      </a:pPr>
+                      <a:r>
+                        <a:t>Named owner(s)</a:t>
+                      </a:r>
+                    </a:p>
+                  </a:txBody>
+                  <a:tcPr marL="64008" marR="64008" marT="36576" marB="36576" anchor="ctr">
+                    <a:solidFill>
+                      <a:srgbClr val="3A96FF"/>
+                    </a:solidFill>
+                  </a:tcPr>
+                </a:tc>
+                <a:tc>
+                  <a:txBody>
+                    <a:bodyPr/>
+                    <a:lstStyle/>
+                    <a:p>
+                      <a:pPr algn="l">
+                        <a:defRPr sz="1300" b="1">
+                          <a:solidFill>
+                            <a:srgbClr val="0A1422"/>
+                          </a:solidFill>
+                          <a:latin typeface="Aptos"/>
+                        </a:defRPr>
+                      </a:pPr>
+                      <a:r>
+                        <a:t>Evidence required</a:t>
+                      </a:r>
+                    </a:p>
+                  </a:txBody>
+                  <a:tcPr marL="64008" marR="64008" marT="36576" marB="36576" anchor="ctr">
+                    <a:solidFill>
+                      <a:srgbClr val="3A96FF"/>
+                    </a:solidFill>
+                  </a:tcPr>
+                </a:tc>
+              </a:tr>
+              <a:tr h="630935">
+                <a:tc>
+                  <a:txBody>
+                    <a:bodyPr/>
+                    <a:lstStyle/>
+                    <a:p>
+                      <a:pPr algn="l">
+                        <a:defRPr sz="1300" b="0">
+                          <a:solidFill>
+                            <a:srgbClr val="F4F8FC"/>
+                          </a:solidFill>
+                          <a:latin typeface="Aptos"/>
+                        </a:defRPr>
+                      </a:pPr>
+                      <a:r>
+                        <a:t>Data acquisition and schema</a:t>
+                      </a:r>
+                    </a:p>
+                  </a:txBody>
+                  <a:tcPr marL="64008" marR="64008" marT="36576" marB="36576" anchor="ctr">
+                    <a:solidFill>
+                      <a:srgbClr val="142234"/>
+                    </a:solidFill>
+                  </a:tcPr>
+                </a:tc>
+                <a:tc>
+                  <a:txBody>
+                    <a:bodyPr/>
+                    <a:lstStyle/>
+                    <a:p>
+                      <a:pPr algn="l">
+                        <a:defRPr sz="1300" b="0">
+                          <a:solidFill>
+                            <a:srgbClr val="F4F8FC"/>
+                          </a:solidFill>
+                          <a:latin typeface="Aptos"/>
+                        </a:defRPr>
+                      </a:pPr>
+                      <a:r>
+                        <a:t>Team to fill</a:t>
+                      </a:r>
+                    </a:p>
+                  </a:txBody>
+                  <a:tcPr marL="64008" marR="64008" marT="36576" marB="36576" anchor="ctr">
+                    <a:solidFill>
+                      <a:srgbClr val="142234"/>
+                    </a:solidFill>
+                  </a:tcPr>
+                </a:tc>
+                <a:tc>
+                  <a:txBody>
+                    <a:bodyPr/>
+                    <a:lstStyle/>
+                    <a:p>
+                      <a:pPr algn="l">
+                        <a:defRPr sz="1300" b="0">
+                          <a:solidFill>
+                            <a:srgbClr val="F4F8FC"/>
+                          </a:solidFill>
+                          <a:latin typeface="Aptos"/>
+                        </a:defRPr>
+                      </a:pPr>
+                      <a:r>
+                        <a:t>Original commit/PR + dataset notes</a:t>
+                      </a:r>
+                    </a:p>
+                  </a:txBody>
+                  <a:tcPr marL="64008" marR="64008" marT="36576" marB="36576" anchor="ctr">
+                    <a:solidFill>
+                      <a:srgbClr val="142234"/>
+                    </a:solidFill>
+                  </a:tcPr>
+                </a:tc>
+              </a:tr>
+              <a:tr h="630935">
+                <a:tc>
+                  <a:txBody>
+                    <a:bodyPr/>
+                    <a:lstStyle/>
+                    <a:p>
+                      <a:pPr algn="l">
+                        <a:defRPr sz="1300" b="0">
+                          <a:solidFill>
+                            <a:srgbClr val="F4F8FC"/>
+                          </a:solidFill>
+                          <a:latin typeface="Aptos"/>
+                        </a:defRPr>
+                      </a:pPr>
+                      <a:r>
+                        <a:t>Preprocessing and time semantics</a:t>
+                      </a:r>
+                    </a:p>
+                  </a:txBody>
+                  <a:tcPr marL="64008" marR="64008" marT="36576" marB="36576" anchor="ctr">
+                    <a:solidFill>
+                      <a:srgbClr val="1A2B40"/>
+                    </a:solidFill>
+                  </a:tcPr>
+                </a:tc>
+                <a:tc>
+                  <a:txBody>
+                    <a:bodyPr/>
+                    <a:lstStyle/>
+                    <a:p>
+                      <a:pPr algn="l">
+                        <a:defRPr sz="1300" b="0">
+                          <a:solidFill>
+                            <a:srgbClr val="F4F8FC"/>
+                          </a:solidFill>
+                          <a:latin typeface="Aptos"/>
+                        </a:defRPr>
+                      </a:pPr>
+                      <a:r>
+                        <a:t>Team to fill</a:t>
+                      </a:r>
+                    </a:p>
+                  </a:txBody>
+                  <a:tcPr marL="64008" marR="64008" marT="36576" marB="36576" anchor="ctr">
+                    <a:solidFill>
+                      <a:srgbClr val="1A2B40"/>
+                    </a:solidFill>
+                  </a:tcPr>
+                </a:tc>
+                <a:tc>
+                  <a:txBody>
+                    <a:bodyPr/>
+                    <a:lstStyle/>
+                    <a:p>
+                      <a:pPr algn="l">
+                        <a:defRPr sz="1300" b="0">
+                          <a:solidFill>
+                            <a:srgbClr val="F4F8FC"/>
+                          </a:solidFill>
+                          <a:latin typeface="Aptos"/>
+                        </a:defRPr>
+                      </a:pPr>
+                      <a:r>
+                        <a:t>Tests + before/after counts</a:t>
+                      </a:r>
+                    </a:p>
+                  </a:txBody>
+                  <a:tcPr marL="64008" marR="64008" marT="36576" marB="36576" anchor="ctr">
+                    <a:solidFill>
+                      <a:srgbClr val="1A2B40"/>
+                    </a:solidFill>
+                  </a:tcPr>
+                </a:tc>
+              </a:tr>
+              <a:tr h="630935">
+                <a:tc>
+                  <a:txBody>
+                    <a:bodyPr/>
+                    <a:lstStyle/>
+                    <a:p>
+                      <a:pPr algn="l">
+                        <a:defRPr sz="1300" b="0">
+                          <a:solidFill>
+                            <a:srgbClr val="F4F8FC"/>
+                          </a:solidFill>
+                          <a:latin typeface="Aptos"/>
+                        </a:defRPr>
+                      </a:pPr>
+                      <a:r>
+                        <a:t>Metric/log/trace agents</a:t>
+                      </a:r>
+                    </a:p>
+                  </a:txBody>
+                  <a:tcPr marL="64008" marR="64008" marT="36576" marB="36576" anchor="ctr">
+                    <a:solidFill>
+                      <a:srgbClr val="142234"/>
+                    </a:solidFill>
+                  </a:tcPr>
+                </a:tc>
+                <a:tc>
+                  <a:txBody>
+                    <a:bodyPr/>
+                    <a:lstStyle/>
+                    <a:p>
+                      <a:pPr algn="l">
+                        <a:defRPr sz="1300" b="0">
+                          <a:solidFill>
+                            <a:srgbClr val="F4F8FC"/>
+                          </a:solidFill>
+                          <a:latin typeface="Aptos"/>
+                        </a:defRPr>
+                      </a:pPr>
+                      <a:r>
+                        <a:t>Team to fill</a:t>
+                      </a:r>
+                    </a:p>
+                  </a:txBody>
+                  <a:tcPr marL="64008" marR="64008" marT="36576" marB="36576" anchor="ctr">
+                    <a:solidFill>
+                      <a:srgbClr val="142234"/>
+                    </a:solidFill>
+                  </a:tcPr>
+                </a:tc>
+                <a:tc>
+                  <a:txBody>
+                    <a:bodyPr/>
+                    <a:lstStyle/>
+                    <a:p>
+                      <a:pPr algn="l">
+                        <a:defRPr sz="1300" b="0">
+                          <a:solidFill>
+                            <a:srgbClr val="F4F8FC"/>
+                          </a:solidFill>
+                          <a:latin typeface="Aptos"/>
+                        </a:defRPr>
+                      </a:pPr>
+                      <a:r>
+                        <a:t>Module commits + one traced case</a:t>
+                      </a:r>
+                    </a:p>
+                  </a:txBody>
+                  <a:tcPr marL="64008" marR="64008" marT="36576" marB="36576" anchor="ctr">
+                    <a:solidFill>
+                      <a:srgbClr val="142234"/>
+                    </a:solidFill>
+                  </a:tcPr>
+                </a:tc>
+              </a:tr>
+              <a:tr h="630935">
+                <a:tc>
+                  <a:txBody>
+                    <a:bodyPr/>
+                    <a:lstStyle/>
+                    <a:p>
+                      <a:pPr algn="l">
+                        <a:defRPr sz="1300" b="0">
+                          <a:solidFill>
+                            <a:srgbClr val="F4F8FC"/>
+                          </a:solidFill>
+                          <a:latin typeface="Aptos"/>
+                        </a:defRPr>
+                      </a:pPr>
+                      <a:r>
+                        <a:t>Reasoning, persistence, and UI</a:t>
+                      </a:r>
+                    </a:p>
+                  </a:txBody>
+                  <a:tcPr marL="64008" marR="64008" marT="36576" marB="36576" anchor="ctr">
+                    <a:solidFill>
+                      <a:srgbClr val="1A2B40"/>
+                    </a:solidFill>
+                  </a:tcPr>
+                </a:tc>
+                <a:tc>
+                  <a:txBody>
+                    <a:bodyPr/>
+                    <a:lstStyle/>
+                    <a:p>
+                      <a:pPr algn="l">
+                        <a:defRPr sz="1300" b="0">
+                          <a:solidFill>
+                            <a:srgbClr val="F4F8FC"/>
+                          </a:solidFill>
+                          <a:latin typeface="Aptos"/>
+                        </a:defRPr>
+                      </a:pPr>
+                      <a:r>
+                        <a:t>Team to fill</a:t>
+                      </a:r>
+                    </a:p>
+                  </a:txBody>
+                  <a:tcPr marL="64008" marR="64008" marT="36576" marB="36576" anchor="ctr">
+                    <a:solidFill>
+                      <a:srgbClr val="1A2B40"/>
+                    </a:solidFill>
+                  </a:tcPr>
+                </a:tc>
+                <a:tc>
+                  <a:txBody>
+                    <a:bodyPr/>
+                    <a:lstStyle/>
+                    <a:p>
+                      <a:pPr algn="l">
+                        <a:defRPr sz="1300" b="0">
+                          <a:solidFill>
+                            <a:srgbClr val="F4F8FC"/>
+                          </a:solidFill>
+                          <a:latin typeface="Aptos"/>
+                        </a:defRPr>
+                      </a:pPr>
+                      <a:r>
+                        <a:t>Commit/PR + saved run/demo</a:t>
+                      </a:r>
+                    </a:p>
+                  </a:txBody>
+                  <a:tcPr marL="64008" marR="64008" marT="36576" marB="36576" anchor="ctr">
+                    <a:solidFill>
+                      <a:srgbClr val="1A2B40"/>
+                    </a:solidFill>
+                  </a:tcPr>
+                </a:tc>
+              </a:tr>
+              <a:tr h="630940">
+                <a:tc>
+                  <a:txBody>
+                    <a:bodyPr/>
+                    <a:lstStyle/>
+                    <a:p>
+                      <a:pPr algn="l">
+                        <a:defRPr sz="1300" b="0">
+                          <a:solidFill>
+                            <a:srgbClr val="F4F8FC"/>
+                          </a:solidFill>
+                          <a:latin typeface="Aptos"/>
+                        </a:defRPr>
+                      </a:pPr>
+                      <a:r>
+                        <a:t>Evaluation and presentation</a:t>
+                      </a:r>
+                    </a:p>
+                  </a:txBody>
+                  <a:tcPr marL="64008" marR="64008" marT="36576" marB="36576" anchor="ctr">
+                    <a:solidFill>
+                      <a:srgbClr val="142234"/>
+                    </a:solidFill>
+                  </a:tcPr>
+                </a:tc>
+                <a:tc>
+                  <a:txBody>
+                    <a:bodyPr/>
+                    <a:lstStyle/>
+                    <a:p>
+                      <a:pPr algn="l">
+                        <a:defRPr sz="1300" b="0">
+                          <a:solidFill>
+                            <a:srgbClr val="F4F8FC"/>
+                          </a:solidFill>
+                          <a:latin typeface="Aptos"/>
+                        </a:defRPr>
+                      </a:pPr>
+                      <a:r>
+                        <a:t>Team to fill</a:t>
+                      </a:r>
+                    </a:p>
+                  </a:txBody>
+                  <a:tcPr marL="64008" marR="64008" marT="36576" marB="36576" anchor="ctr">
+                    <a:solidFill>
+                      <a:srgbClr val="142234"/>
+                    </a:solidFill>
+                  </a:tcPr>
+                </a:tc>
+                <a:tc>
+                  <a:txBody>
+                    <a:bodyPr/>
+                    <a:lstStyle/>
+                    <a:p>
+                      <a:pPr algn="l">
+                        <a:defRPr sz="1300" b="0">
+                          <a:solidFill>
+                            <a:srgbClr val="F4F8FC"/>
+                          </a:solidFill>
+                          <a:latin typeface="Aptos"/>
+                        </a:defRPr>
+                      </a:pPr>
+                      <a:r>
+                        <a:t>Scorer artifact + slide owner</a:t>
+                      </a:r>
+                    </a:p>
+                  </a:txBody>
+                  <a:tcPr marL="64008" marR="64008" marT="36576" marB="36576" anchor="ctr">
+                    <a:solidFill>
+                      <a:srgbClr val="142234"/>
+                    </a:solidFill>
+                  </a:tcPr>
+                </a:tc>
+              </a:tr>
+            </a:tbl>
+          </a:graphicData>
+        </a:graphic>
+      </p:graphicFrame>
       <p:sp>
         <p:nvSpPr>
           <p:cNvPr id="7" name="TextBox 6"/>
+          <p:cNvSpPr txBox="1"/>
+          <p:nvPr/>
+        </p:nvSpPr>
+        <p:spPr>
+          <a:xfrm>
+            <a:off x="658368" y="5650992"/>
+            <a:ext cx="10835640" cy="685800"/>
+          </a:xfrm>
+          <a:prstGeom prst="rect">
+            <a:avLst/>
+          </a:prstGeom>
+          <a:noFill/>
+        </p:spPr>
+        <p:txBody>
+          <a:bodyPr wrap="square" lIns="36576" rIns="36576" tIns="18288" bIns="18288" anchor="t">
+            <a:spAutoFit/>
+          </a:bodyPr>
+          <a:lstStyle/>
+          <a:p>
+            <a:pPr>
+              <a:spcAft>
+                <a:spcPts val="200"/>
+              </a:spcAft>
+              <a:defRPr sz="1450" b="0">
+                <a:solidFill>
+                  <a:srgbClr val="FFBE50"/>
+                </a:solidFill>
+                <a:latin typeface="Aptos"/>
+              </a:defRPr>
+            </a:pPr>
+            <a:r>
+              <a:t>The review commits repair and document the shared code; they do not establish</a:t>
+            </a:r>
+            <a:br/>
+            <a:r>
+              <a:t>which student authored the original modules. Teacher evaluation should reconcile</a:t>
+            </a:r>
+            <a:br/>
+            <a:r>
+              <a:t>the table with Git history and a short individual explanation.</a:t>
+            </a:r>
+          </a:p>
+        </p:txBody>
+      </p:sp>
+      <p:sp>
+        <p:nvSpPr>
+          <p:cNvPr id="8" name="TextBox 7"/>
           <p:cNvSpPr txBox="1"/>
           <p:nvPr/>
         </p:nvSpPr>
@@ -6452,7 +6889,7 @@
       </p:sp>
       <p:sp>
         <p:nvSpPr>
-          <p:cNvPr id="8" name="TextBox 7"/>
+          <p:cNvPr id="9" name="TextBox 8"/>
           <p:cNvSpPr txBox="1"/>
           <p:nvPr/>
         </p:nvSpPr>
@@ -6592,7 +7029,7 @@
               </a:defRPr>
             </a:pPr>
             <a:r>
-              <a:t>Conclusion and next steps</a:t>
+              <a:t>Completeness gate</a:t>
             </a:r>
           </a:p>
         </p:txBody>
@@ -6719,60 +7156,48 @@
               </a:defRPr>
             </a:pPr>
             <a:r>
-              <a:t>WHAT EXISTS</a:t>
-            </a:r>
-            <a:br/>
-            <a:br/>
-            <a:r>
-              <a:t>A broad Jira/telemetry/database/agent implementation, a safe mock baseline, and</a:t>
-            </a:r>
-            <a:br/>
-            <a:r>
-              <a:t>one controlled real multimodal integration run.</a:t>
-            </a:r>
-            <a:br/>
-            <a:br/>
-            <a:r>
-              <a:t>WHAT THE EVIDENCE CURRENTLY SAYS</a:t>
-            </a:r>
-            <a:br/>
-            <a:br/>
-            <a:r>
-              <a:t>Software repair and one-case integration checks pass, but no multi-case Market</a:t>
-            </a:r>
-            <a:br/>
-            <a:r>
-              <a:t>evaluation supports an accuracy claim yet.</a:t>
-            </a:r>
-            <a:br/>
-            <a:br/>
-            <a:r>
-              <a:t>BEFORE THE FINAL SESSION</a:t>
-            </a:r>
-            <a:br/>
-            <a:br/>
-            <a:r>
-              <a:t>1. freeze a small held-out Market manifest;</a:t>
-            </a:r>
-            <a:br/>
-            <a:r>
-              <a:t>2. generate preparation/EDA evidence;</a:t>
-            </a:r>
-            <a:br/>
-            <a:r>
-              <a:t>3. choose baseline versus submitted method;</a:t>
-            </a:r>
-            <a:br/>
-            <a:r>
-              <a:t>4. resolve/score replica normalization exposed by task_6;</a:t>
-            </a:r>
-            <a:br/>
-            <a:r>
-              <a:t>5. score multiple frozen cases with canonical reason/component normalization;</a:t>
-            </a:r>
-            <a:br/>
-            <a:r>
-              <a:t>6. preserve per-case outputs, model/version, latency, and cost.</a:t>
+              <a:t>• [x] Market dataset card plus 20-file byte/SHA-256 manifest.</a:t>
+            </a:r>
+            <a:br/>
+            <a:r>
+              <a:t>• [ ] Real-data preparation report and executed EDA figures.</a:t>
+            </a:r>
+            <a:br/>
+            <a:r>
+              <a:t>• [ ] One chosen submitted method, baseline, split, and metric definition.</a:t>
+            </a:r>
+            <a:br/>
+            <a:r>
+              <a:t>• [x] Metric-only loader/time-window contract tested on one real case.</a:t>
+            </a:r>
+            <a:br/>
+            <a:r>
+              <a:t>• [x] Full method run once against a disposable/local DB with no live write.</a:t>
+            </a:r>
+            <a:br/>
+            <a:r>
+              <a:t>• [ ] Per-case result table, ablation, two failures, one success.</a:t>
+            </a:r>
+            <a:br/>
+            <a:r>
+              <a:t>• [ ] UI/demo displays a real saved RCA or is scoped honestly.</a:t>
+            </a:r>
+            <a:br/>
+            <a:r>
+              <a:t>• [ ] Fresh-clone setup/run log and dependency/config manifest.</a:t>
+            </a:r>
+            <a:br/>
+            <a:r>
+              <a:t>• [ ] Citations, contributions, security, and limitations reviewed.</a:t>
+            </a:r>
+            <a:br/>
+            <a:br/>
+            <a:r>
+              <a:t>Completeness means that a teacher can trace dataset → query → telemetry → method</a:t>
+            </a:r>
+            <a:br/>
+            <a:r>
+              <a:t>→ prediction → ground truth → score without receiving a secret.</a:t>
             </a:r>
           </a:p>
         </p:txBody>
@@ -6958,7 +7383,7 @@
               </a:defRPr>
             </a:pPr>
             <a:r>
-              <a:t>Appendix — reproducibility and citations</a:t>
+              <a:t>Conclusion and next steps</a:t>
             </a:r>
           </a:p>
         </p:txBody>
@@ -7085,55 +7510,60 @@
               </a:defRPr>
             </a:pPr>
             <a:r>
-              <a:t>Record in the final deck:</a:t>
-            </a:r>
-            <a:br/>
-            <a:br/>
-            <a:r>
-              <a:t>  Repository: github.com/ThienHuynhNgoc/OpenRCA_DTH</a:t>
-            </a:r>
-            <a:br/>
-            <a:r>
-              <a:t>  Branch:     codex/dth-capstone-review-2026-08-09</a:t>
-            </a:r>
-            <a:br/>
-            <a:r>
-              <a:t>  Code commit: 3f99de3</a:t>
-            </a:r>
-            <a:br/>
-            <a:r>
-              <a:t>  Dataset:    docs/review/market_cloudbed1_file_manifest_2026-08-09.tsv</a:t>
-            </a:r>
-            <a:br/>
-            <a:r>
-              <a:t>  Command:    &lt;exact baseline and full-method commands&gt;</a:t>
-            </a:r>
-            <a:br/>
-            <a:r>
-              <a:t>  Results:    docs/review/full_pipeline_local_integration_2026-08-09.md</a:t>
-            </a:r>
-            <a:br/>
-            <a:br/>
-            <a:r>
-              <a:t>Primary sources:</a:t>
-            </a:r>
-            <a:br/>
-            <a:br/>
-            <a:r>
-              <a:t>• Microsoft OpenRCA repository: https://github.com/microsoft/OpenRCA</a:t>
-            </a:r>
-            <a:br/>
-            <a:r>
-              <a:t>• OpenRCA paper, ICLR 2025: https://openreview.net/forum?id=M4qNIzQYpd</a:t>
-            </a:r>
-            <a:br/>
-            <a:br/>
-            <a:r>
-              <a:t>Add canonical citations for comparison methods. The upstream paper's reported</a:t>
-            </a:r>
-            <a:br/>
-            <a:r>
-              <a:t>accuracy is not this team's accuracy.</a:t>
+              <a:t>WHAT EXISTS</a:t>
+            </a:r>
+            <a:br/>
+            <a:br/>
+            <a:r>
+              <a:t>A broad Jira/telemetry/database/agent implementation, a safe mock baseline, and</a:t>
+            </a:r>
+            <a:br/>
+            <a:r>
+              <a:t>one controlled real multimodal integration run.</a:t>
+            </a:r>
+            <a:br/>
+            <a:br/>
+            <a:r>
+              <a:t>WHAT THE EVIDENCE CURRENTLY SAYS</a:t>
+            </a:r>
+            <a:br/>
+            <a:br/>
+            <a:r>
+              <a:t>Software repair and one-case integration checks pass, but no multi-case Market</a:t>
+            </a:r>
+            <a:br/>
+            <a:r>
+              <a:t>evaluation supports an accuracy claim yet.</a:t>
+            </a:r>
+            <a:br/>
+            <a:br/>
+            <a:r>
+              <a:t>BEFORE THE FINAL SESSION</a:t>
+            </a:r>
+            <a:br/>
+            <a:br/>
+            <a:r>
+              <a:t>1. freeze a small held-out Market manifest;</a:t>
+            </a:r>
+            <a:br/>
+            <a:r>
+              <a:t>2. generate preparation/EDA evidence;</a:t>
+            </a:r>
+            <a:br/>
+            <a:r>
+              <a:t>3. choose baseline versus submitted method;</a:t>
+            </a:r>
+            <a:br/>
+            <a:r>
+              <a:t>4. resolve/score replica normalization exposed by task_6;</a:t>
+            </a:r>
+            <a:br/>
+            <a:r>
+              <a:t>5. score multiple frozen cases with canonical reason/component normalization;</a:t>
+            </a:r>
+            <a:br/>
+            <a:r>
+              <a:t>6. preserve per-case outputs, model/version, latency, and cost.</a:t>
             </a:r>
           </a:p>
         </p:txBody>
@@ -7212,6 +7642,387 @@
             </a:pPr>
             <a:r>
               <a:t>17</a:t>
+            </a:r>
+          </a:p>
+        </p:txBody>
+      </p:sp>
+    </p:spTree>
+  </p:cSld>
+  <p:clrMapOvr>
+    <a:masterClrMapping/>
+  </p:clrMapOvr>
+</p:sld>
+</file>
+
+<file path=ppt/slides/slide18.xml><?xml version="1.0" encoding="utf-8"?>
+<p:sld xmlns:a="http://schemas.openxmlformats.org/drawingml/2006/main" xmlns:p="http://schemas.openxmlformats.org/presentationml/2006/main" xmlns:r="http://schemas.openxmlformats.org/officeDocument/2006/relationships">
+  <p:cSld>
+    <p:bg>
+      <p:bgPr>
+        <a:solidFill>
+          <a:srgbClr val="0A1422"/>
+        </a:solidFill>
+        <a:effectLst/>
+      </p:bgPr>
+    </p:bg>
+    <p:spTree>
+      <p:nvGrpSpPr>
+        <p:cNvPr id="1" name=""/>
+        <p:cNvGrpSpPr/>
+        <p:nvPr/>
+      </p:nvGrpSpPr>
+      <p:grpSpPr/>
+      <p:sp>
+        <p:nvSpPr>
+          <p:cNvPr id="2" name="Rectangle 1"/>
+          <p:cNvSpPr/>
+          <p:nvPr/>
+        </p:nvSpPr>
+        <p:spPr>
+          <a:xfrm>
+            <a:off x="0" y="0"/>
+            <a:ext cx="128016" cy="6858000"/>
+          </a:xfrm>
+          <a:prstGeom prst="rect">
+            <a:avLst/>
+          </a:prstGeom>
+          <a:solidFill>
+            <a:srgbClr val="3A96FF"/>
+          </a:solidFill>
+          <a:ln>
+            <a:noFill/>
+          </a:ln>
+        </p:spPr>
+        <p:style>
+          <a:lnRef idx="1">
+            <a:schemeClr val="accent1"/>
+          </a:lnRef>
+          <a:fillRef idx="3">
+            <a:schemeClr val="accent1"/>
+          </a:fillRef>
+          <a:effectRef idx="2">
+            <a:schemeClr val="accent1"/>
+          </a:effectRef>
+          <a:fontRef idx="minor">
+            <a:schemeClr val="lt1"/>
+          </a:fontRef>
+        </p:style>
+        <p:txBody>
+          <a:bodyPr rtlCol="0" anchor="ctr"/>
+          <a:lstStyle/>
+          <a:p>
+            <a:pPr algn="ctr"/>
+          </a:p>
+        </p:txBody>
+      </p:sp>
+      <p:sp>
+        <p:nvSpPr>
+          <p:cNvPr id="3" name="TextBox 2"/>
+          <p:cNvSpPr txBox="1"/>
+          <p:nvPr/>
+        </p:nvSpPr>
+        <p:spPr>
+          <a:xfrm>
+            <a:off x="566928" y="320040"/>
+            <a:ext cx="10927080" cy="566928"/>
+          </a:xfrm>
+          <a:prstGeom prst="rect">
+            <a:avLst/>
+          </a:prstGeom>
+          <a:noFill/>
+        </p:spPr>
+        <p:txBody>
+          <a:bodyPr wrap="square" lIns="36576" rIns="36576" tIns="18288" bIns="18288" anchor="t">
+            <a:spAutoFit/>
+          </a:bodyPr>
+          <a:lstStyle/>
+          <a:p>
+            <a:pPr>
+              <a:spcAft>
+                <a:spcPts val="200"/>
+              </a:spcAft>
+              <a:defRPr sz="2800" b="1">
+                <a:solidFill>
+                  <a:srgbClr val="F4F8FC"/>
+                </a:solidFill>
+                <a:latin typeface="Aptos"/>
+              </a:defRPr>
+            </a:pPr>
+            <a:r>
+              <a:t>Appendix — reproducibility and citations</a:t>
+            </a:r>
+          </a:p>
+        </p:txBody>
+      </p:sp>
+      <p:sp>
+        <p:nvSpPr>
+          <p:cNvPr id="4" name="Rectangle 3"/>
+          <p:cNvSpPr/>
+          <p:nvPr/>
+        </p:nvSpPr>
+        <p:spPr>
+          <a:xfrm>
+            <a:off x="603504" y="950976"/>
+            <a:ext cx="1234440" cy="50292"/>
+          </a:xfrm>
+          <a:prstGeom prst="rect">
+            <a:avLst/>
+          </a:prstGeom>
+          <a:solidFill>
+            <a:srgbClr val="3A96FF"/>
+          </a:solidFill>
+          <a:ln>
+            <a:noFill/>
+          </a:ln>
+        </p:spPr>
+        <p:style>
+          <a:lnRef idx="1">
+            <a:schemeClr val="accent1"/>
+          </a:lnRef>
+          <a:fillRef idx="3">
+            <a:schemeClr val="accent1"/>
+          </a:fillRef>
+          <a:effectRef idx="2">
+            <a:schemeClr val="accent1"/>
+          </a:effectRef>
+          <a:fontRef idx="minor">
+            <a:schemeClr val="lt1"/>
+          </a:fontRef>
+        </p:style>
+        <p:txBody>
+          <a:bodyPr rtlCol="0" anchor="ctr"/>
+          <a:lstStyle/>
+          <a:p>
+            <a:pPr algn="ctr"/>
+          </a:p>
+        </p:txBody>
+      </p:sp>
+      <p:sp>
+        <p:nvSpPr>
+          <p:cNvPr id="5" name="Rounded Rectangle 4"/>
+          <p:cNvSpPr/>
+          <p:nvPr/>
+        </p:nvSpPr>
+        <p:spPr>
+          <a:xfrm>
+            <a:off x="603504" y="1097280"/>
+            <a:ext cx="10991088" cy="5221223"/>
+          </a:xfrm>
+          <a:prstGeom prst="roundRect">
+            <a:avLst/>
+          </a:prstGeom>
+          <a:solidFill>
+            <a:srgbClr val="142234"/>
+          </a:solidFill>
+          <a:ln>
+            <a:solidFill>
+              <a:srgbClr val="22364C"/>
+            </a:solidFill>
+          </a:ln>
+        </p:spPr>
+        <p:style>
+          <a:lnRef idx="1">
+            <a:schemeClr val="accent1"/>
+          </a:lnRef>
+          <a:fillRef idx="3">
+            <a:schemeClr val="accent1"/>
+          </a:fillRef>
+          <a:effectRef idx="2">
+            <a:schemeClr val="accent1"/>
+          </a:effectRef>
+          <a:fontRef idx="minor">
+            <a:schemeClr val="lt1"/>
+          </a:fontRef>
+        </p:style>
+        <p:txBody>
+          <a:bodyPr rtlCol="0" anchor="ctr"/>
+          <a:lstStyle/>
+          <a:p>
+            <a:pPr algn="ctr"/>
+          </a:p>
+        </p:txBody>
+      </p:sp>
+      <p:sp>
+        <p:nvSpPr>
+          <p:cNvPr id="6" name="TextBox 5"/>
+          <p:cNvSpPr txBox="1"/>
+          <p:nvPr/>
+        </p:nvSpPr>
+        <p:spPr>
+          <a:xfrm>
+            <a:off x="768096" y="1207008"/>
+            <a:ext cx="10625328" cy="5038344"/>
+          </a:xfrm>
+          <a:prstGeom prst="rect">
+            <a:avLst/>
+          </a:prstGeom>
+          <a:noFill/>
+        </p:spPr>
+        <p:txBody>
+          <a:bodyPr wrap="square" lIns="36576" rIns="36576" tIns="18288" bIns="18288" anchor="t">
+            <a:spAutoFit/>
+          </a:bodyPr>
+          <a:lstStyle/>
+          <a:p>
+            <a:pPr>
+              <a:spcAft>
+                <a:spcPts val="200"/>
+              </a:spcAft>
+              <a:defRPr sz="1300" b="0">
+                <a:solidFill>
+                  <a:srgbClr val="F4F8FC"/>
+                </a:solidFill>
+                <a:latin typeface="Aptos"/>
+              </a:defRPr>
+            </a:pPr>
+            <a:r>
+              <a:t>Record in the final deck:</a:t>
+            </a:r>
+            <a:br/>
+            <a:br/>
+            <a:r>
+              <a:t>  Repository: github.com/ThienHuynhNgoc/OpenRCA_DTH</a:t>
+            </a:r>
+            <a:br/>
+            <a:r>
+              <a:t>  Branch:     codex/dth-capstone-review-2026-08-09</a:t>
+            </a:r>
+            <a:br/>
+            <a:r>
+              <a:t>  Code commit: 3f99de3</a:t>
+            </a:r>
+            <a:br/>
+            <a:r>
+              <a:t>  Evidence commits through: 9a08ffd</a:t>
+            </a:r>
+            <a:br/>
+            <a:r>
+              <a:t>  Dataset:    docs/review/market_cloudbed1_file_manifest_2026-08-09.tsv</a:t>
+            </a:r>
+            <a:br/>
+            <a:r>
+              <a:t>  Dry run:    python -m src.full_pipeline --raw-query-file local-query.json \</a:t>
+            </a:r>
+            <a:br/>
+            <a:r>
+              <a:t>  --data-root /absolute/path/to/Market --dataset cloudbed-1 \</a:t>
+            </a:r>
+            <a:br/>
+            <a:r>
+              <a:t>  --timestamp-offset-hours 8</a:t>
+            </a:r>
+            <a:br/>
+            <a:r>
+              <a:t>  Integration: same command plus --write-database --run-agents, against a \</a:t>
+            </a:r>
+            <a:br/>
+            <a:r>
+              <a:t>  disposable loopback-only PostgreSQL target</a:t>
+            </a:r>
+            <a:br/>
+            <a:r>
+              <a:t>  Results:    docs/review/full_pipeline_local_integration_2026-08-09.md</a:t>
+            </a:r>
+            <a:br/>
+            <a:br/>
+            <a:r>
+              <a:t>Primary sources:</a:t>
+            </a:r>
+            <a:br/>
+            <a:br/>
+            <a:r>
+              <a:t>• Microsoft OpenRCA repository: https://github.com/microsoft/OpenRCA</a:t>
+            </a:r>
+            <a:br/>
+            <a:r>
+              <a:t>• OpenRCA paper, ICLR 2025: https://openreview.net/forum?id=M4qNIzQYpd</a:t>
+            </a:r>
+            <a:br/>
+            <a:br/>
+            <a:r>
+              <a:t>Add canonical citations for comparison methods. The upstream paper's reported</a:t>
+            </a:r>
+            <a:br/>
+            <a:r>
+              <a:t>accuracy is not this team's accuracy.</a:t>
+            </a:r>
+          </a:p>
+        </p:txBody>
+      </p:sp>
+      <p:sp>
+        <p:nvSpPr>
+          <p:cNvPr id="7" name="TextBox 6"/>
+          <p:cNvSpPr txBox="1"/>
+          <p:nvPr/>
+        </p:nvSpPr>
+        <p:spPr>
+          <a:xfrm>
+            <a:off x="621792" y="6510528"/>
+            <a:ext cx="8046720" cy="201168"/>
+          </a:xfrm>
+          <a:prstGeom prst="rect">
+            <a:avLst/>
+          </a:prstGeom>
+          <a:noFill/>
+        </p:spPr>
+        <p:txBody>
+          <a:bodyPr wrap="square" lIns="36576" rIns="36576" tIns="18288" bIns="18288" anchor="t">
+            <a:spAutoFit/>
+          </a:bodyPr>
+          <a:lstStyle/>
+          <a:p>
+            <a:pPr>
+              <a:spcAft>
+                <a:spcPts val="200"/>
+              </a:spcAft>
+              <a:defRPr sz="950" b="0">
+                <a:solidFill>
+                  <a:srgbClr val="AEC0D2"/>
+                </a:solidFill>
+                <a:latin typeface="Aptos"/>
+              </a:defRPr>
+            </a:pPr>
+            <a:r>
+              <a:t>OpenRCA • DTH • 9 Aug 2026</a:t>
+            </a:r>
+          </a:p>
+        </p:txBody>
+      </p:sp>
+      <p:sp>
+        <p:nvSpPr>
+          <p:cNvPr id="8" name="TextBox 7"/>
+          <p:cNvSpPr txBox="1"/>
+          <p:nvPr/>
+        </p:nvSpPr>
+        <p:spPr>
+          <a:xfrm>
+            <a:off x="10698480" y="6473952"/>
+            <a:ext cx="731520" cy="228600"/>
+          </a:xfrm>
+          <a:prstGeom prst="rect">
+            <a:avLst/>
+          </a:prstGeom>
+          <a:noFill/>
+        </p:spPr>
+        <p:txBody>
+          <a:bodyPr wrap="square" lIns="36576" rIns="36576" tIns="18288" bIns="18288" anchor="t">
+            <a:spAutoFit/>
+          </a:bodyPr>
+          <a:lstStyle/>
+          <a:p>
+            <a:pPr algn="r">
+              <a:spcAft>
+                <a:spcPts val="200"/>
+              </a:spcAft>
+              <a:defRPr sz="1000" b="1">
+                <a:solidFill>
+                  <a:srgbClr val="AEC0D2"/>
+                </a:solidFill>
+                <a:latin typeface="Aptos"/>
+              </a:defRPr>
+            </a:pPr>
+            <a:r>
+              <a:t>18</a:t>
             </a:r>
           </a:p>
         </p:txBody>
@@ -7438,7 +8249,7 @@
               <a:spcAft>
                 <a:spcPts val="200"/>
               </a:spcAft>
-              <a:defRPr sz="1800" b="0">
+              <a:defRPr sz="1550" b="0">
                 <a:solidFill>
                   <a:srgbClr val="F4F8FC"/>
                 </a:solidFill>
@@ -7446,7 +8257,11 @@
               </a:defRPr>
             </a:pPr>
             <a:r>
-              <a:t>Given an incident from Jira plus Market metrics, logs, and traces:</a:t>
+              <a:t>Given an incident from Jira or a local RawQuery, plus Market metrics, logs,</a:t>
+            </a:r>
+            <a:br/>
+            <a:r>
+              <a:t>and traces:</a:t>
             </a:r>
             <a:br/>
             <a:br/>
@@ -10126,7 +10941,7 @@
               </a:defRPr>
             </a:pPr>
             <a:r>
-              <a:t>  Jira incident</a:t>
+              <a:t>  Jira incident OR local RawQuery</a:t>
             </a:r>
             <a:br/>
             <a:r>

</xml_diff>

<commit_message>
docs(capstone): replace result placeholders with evidence
</commit_message>
<xml_diff>
--- a/docs/slides/capstone_review_2026-08-09.pptx
+++ b/docs/slides/capstone_review_2026-08-09.pptx
@@ -11378,7 +11378,7 @@
         </p:nvGraphicFramePr>
         <p:xfrm>
           <a:off x="658368" y="2350008"/>
-          <a:ext cx="10835636" cy="3986783"/>
+          <a:ext cx="10835636" cy="3191255"/>
         </p:xfrm>
         <a:graphic>
           <a:graphicData uri="http://schemas.openxmlformats.org/drawingml/2006/table">
@@ -11395,7 +11395,7 @@
                 <a:gridCol w="1547948"/>
                 <a:gridCol w="1547948"/>
               </a:tblGrid>
-              <a:tr h="1328927">
+              <a:tr h="1063751">
                 <a:tc>
                   <a:txBody>
                     <a:bodyPr/>
@@ -11565,7 +11565,7 @@
                   </a:tcPr>
                 </a:tc>
               </a:tr>
-              <a:tr h="1328927">
+              <a:tr h="1063751">
                 <a:tc>
                   <a:txBody>
                     <a:bodyPr/>
@@ -11604,7 +11604,7 @@
                         </a:defRPr>
                       </a:pPr>
                       <a:r>
-                        <a:t>TBD</a:t>
+                        <a:t>1 metric-only diagnostic</a:t>
                       </a:r>
                     </a:p>
                   </a:txBody>
@@ -11628,7 +11628,7 @@
                         </a:defRPr>
                       </a:pPr>
                       <a:r>
-                        <a:t>TBD</a:t>
+                        <a:t>0/1 exact</a:t>
                       </a:r>
                     </a:p>
                   </a:txBody>
@@ -11652,7 +11652,7 @@
                         </a:defRPr>
                       </a:pPr>
                       <a:r>
-                        <a:t>TBD</a:t>
+                        <a:t>0/1 exact</a:t>
                       </a:r>
                     </a:p>
                   </a:txBody>
@@ -11676,7 +11676,7 @@
                         </a:defRPr>
                       </a:pPr>
                       <a:r>
-                        <a:t>TBD</a:t>
+                        <a:t>Not scored</a:t>
                       </a:r>
                     </a:p>
                   </a:txBody>
@@ -11700,7 +11700,7 @@
                         </a:defRPr>
                       </a:pPr>
                       <a:r>
-                        <a:t>TBD</a:t>
+                        <a:t>Not scored</a:t>
                       </a:r>
                     </a:p>
                   </a:txBody>
@@ -11724,7 +11724,7 @@
                         </a:defRPr>
                       </a:pPr>
                       <a:r>
-                        <a:t>TBD</a:t>
+                        <a:t>13.94 s / no AI</a:t>
                       </a:r>
                     </a:p>
                   </a:txBody>
@@ -11735,7 +11735,7 @@
                   </a:tcPr>
                 </a:tc>
               </a:tr>
-              <a:tr h="1328929">
+              <a:tr h="1063753">
                 <a:tc>
                   <a:txBody>
                     <a:bodyPr/>
@@ -11774,7 +11774,7 @@
                         </a:defRPr>
                       </a:pPr>
                       <a:r>
-                        <a:t>TBD</a:t>
+                        <a:t>1 integration smoke</a:t>
                       </a:r>
                     </a:p>
                   </a:txBody>
@@ -11798,7 +11798,7 @@
                         </a:defRPr>
                       </a:pPr>
                       <a:r>
-                        <a:t>TBD</a:t>
+                        <a:t>1/1 component</a:t>
                       </a:r>
                     </a:p>
                   </a:txBody>
@@ -11822,7 +11822,7 @@
                         </a:defRPr>
                       </a:pPr>
                       <a:r>
-                        <a:t>TBD</a:t>
+                        <a:t>Not ranked</a:t>
                       </a:r>
                     </a:p>
                   </a:txBody>
@@ -11846,7 +11846,7 @@
                         </a:defRPr>
                       </a:pPr>
                       <a:r>
-                        <a:t>TBD</a:t>
+                        <a:t>Not canonicalized</a:t>
                       </a:r>
                     </a:p>
                   </a:txBody>
@@ -11870,7 +11870,7 @@
                         </a:defRPr>
                       </a:pPr>
                       <a:r>
-                        <a:t>TBD</a:t>
+                        <a:t>Not scored</a:t>
                       </a:r>
                     </a:p>
                   </a:txBody>
@@ -11894,7 +11894,7 @@
                         </a:defRPr>
                       </a:pPr>
                       <a:r>
-                        <a:t>TBD</a:t>
+                        <a:t>211.03 s / cost not captured</a:t>
                       </a:r>
                     </a:p>
                   </a:txBody>
@@ -11917,6 +11917,53 @@
         </p:nvSpPr>
         <p:spPr>
           <a:xfrm>
+            <a:off x="658368" y="5650992"/>
+            <a:ext cx="10835640" cy="685800"/>
+          </a:xfrm>
+          <a:prstGeom prst="rect">
+            <a:avLst/>
+          </a:prstGeom>
+          <a:noFill/>
+        </p:spPr>
+        <p:txBody>
+          <a:bodyPr wrap="square" lIns="36576" rIns="36576" tIns="18288" bIns="18288" anchor="t">
+            <a:spAutoFit/>
+          </a:bodyPr>
+          <a:lstStyle/>
+          <a:p>
+            <a:pPr>
+              <a:spcAft>
+                <a:spcPts val="200"/>
+              </a:spcAft>
+              <a:defRPr sz="1450" b="0">
+                <a:solidFill>
+                  <a:srgbClr val="F4F8FC"/>
+                </a:solidFill>
+                <a:latin typeface="Aptos"/>
+              </a:defRPr>
+            </a:pPr>
+            <a:r>
+              <a:t>Neither row is a frozen multi-case accuracy estimate. The integration row proves</a:t>
+            </a:r>
+            <a:br/>
+            <a:r>
+              <a:t>execution and persistence only; the team must still produce a prospective</a:t>
+            </a:r>
+            <a:br/>
+            <a:r>
+              <a:t>evaluation manifest and aggregate scorer output.</a:t>
+            </a:r>
+          </a:p>
+        </p:txBody>
+      </p:sp>
+      <p:sp>
+        <p:nvSpPr>
+          <p:cNvPr id="8" name="TextBox 7"/>
+          <p:cNvSpPr txBox="1"/>
+          <p:nvPr/>
+        </p:nvSpPr>
+        <p:spPr>
+          <a:xfrm>
             <a:off x="621792" y="6510528"/>
             <a:ext cx="8046720" cy="201168"/>
           </a:xfrm>
@@ -11950,7 +11997,7 @@
       </p:sp>
       <p:sp>
         <p:nvSpPr>
-          <p:cNvPr id="8" name="TextBox 7"/>
+          <p:cNvPr id="9" name="TextBox 8"/>
           <p:cNvSpPr txBox="1"/>
           <p:nvPr/>
         </p:nvSpPr>

</xml_diff>